<commit_message>
docs: enfocar propuesta MARKINT en valor antes de la inversion
</commit_message>
<xml_diff>
--- a/docs/presentaciones/safe-zone-peru/propuesta-markint/Safe_Zone_Peru_MARKINT_Presentacion.pptx
+++ b/docs/presentaciones/safe-zone-peru/propuesta-markint/Safe_Zone_Peru_MARKINT_Presentacion.pptx
@@ -514,7 +514,7 @@
           <a:lstStyle/>
           <a:p>
             <a:r>
-              <a:t>Presentar a Safe Zone Perú y el alcance propuesto: plataforma desarrollada desde cero, seis semanas y S/ 3,500 de inversión fija. La firma por trazo se describe como firma electrónica de recepción.</a:t>
+              <a:t>Abrir con el valor para MARKINT: procesos adaptados a su operación, información organizada y participación del equipo. La inversión se presenta después de explicar la solución y el alcance.</a:t>
             </a:r>
           </a:p>
         </p:txBody>
@@ -654,7 +654,7 @@
           <a:lstStyle/>
           <a:p>
             <a:r>
-              <a:t>Presentar la inversión fija de S/ 3,500 y el esquema de pago: 40 % al inicio, 30 % con el avance funcional y 30 % contra entrega. El alojamiento y la infraestructura serán asumidos directamente por MARKINT.</a:t>
+              <a:t>Presentar la inversión de S/ 3,500 después del alcance y el cronograma. Explicar los pagos de 40 %, 30 % y 30 %. El alojamiento y la infraestructura serán asumidos directamente por MARKINT.</a:t>
             </a:r>
           </a:p>
         </p:txBody>
@@ -864,7 +864,7 @@
           <a:lstStyle/>
           <a:p>
             <a:r>
-              <a:t>Explicar los beneficios operativos sin prometer resultados cuantitativos que no se han medido.</a:t>
+              <a:t>MARKINT ya trabaja con Buk. Reconocer esa experiencia y presentar la propuesta a medida. El papel futuro de Buk se definirá con MARKINT; no se ha comprometido una integración ni un reemplazo automático.</a:t>
             </a:r>
           </a:p>
         </p:txBody>
@@ -4494,7 +4494,7 @@
               </a:defRPr>
             </a:pPr>
             <a:r>
-              <a:t>SISTEMA INTEGRAL DE GESTIÓN DE RRHH</a:t>
+              <a:t>UNA PLATAFORMA PROPIA DE RECURSOS HUMANOS</a:t>
             </a:r>
           </a:p>
         </p:txBody>
@@ -4533,7 +4533,7 @@
               </a:defRPr>
             </a:pPr>
             <a:r>
-              <a:t>Personas y procesos,</a:t>
+              <a:t>La gestión de su equipo,</a:t>
             </a:r>
           </a:p>
           <a:p>
@@ -4549,7 +4549,7 @@
               </a:defRPr>
             </a:pPr>
             <a:r>
-              <a:t>conectados en una plataforma.</a:t>
+              <a:t>diseñada para MARKINT.</a:t>
             </a:r>
           </a:p>
         </p:txBody>
@@ -4588,7 +4588,7 @@
               </a:defRPr>
             </a:pPr>
             <a:r>
-              <a:t>Una solución web desarrollada a medida para MARKINT.</a:t>
+              <a:t>Procesos a su medida. Información organizada. Un equipo conectado.</a:t>
             </a:r>
           </a:p>
         </p:txBody>
@@ -4740,24 +4740,63 @@
         <p:spPr>
           <a:xfrm>
             <a:off x="777240" y="4114800"/>
-            <a:ext cx="3035808" cy="502920"/>
-          </a:xfrm>
-          <a:prstGeom prst="rect">
-            <a:avLst/>
-          </a:prstGeom>
-          <a:noFill/>
-        </p:spPr>
-        <p:txBody>
-          <a:bodyPr wrap="square" lIns="0" rIns="0" tIns="0" bIns="0">
-            <a:spAutoFit/>
-          </a:bodyPr>
-          <a:lstStyle/>
-          <a:p>
-            <a:pPr>
-              <a:spcAft>
-                <a:spcPts val="700"/>
-              </a:spcAft>
-              <a:defRPr sz="2700" b="1">
+            <a:ext cx="3035808" cy="411480"/>
+          </a:xfrm>
+          <a:prstGeom prst="rect">
+            <a:avLst/>
+          </a:prstGeom>
+          <a:noFill/>
+        </p:spPr>
+        <p:txBody>
+          <a:bodyPr wrap="square" lIns="0" rIns="0" tIns="0" bIns="0">
+            <a:spAutoFit/>
+          </a:bodyPr>
+          <a:lstStyle/>
+          <a:p>
+            <a:pPr>
+              <a:spcAft>
+                <a:spcPts val="700"/>
+              </a:spcAft>
+              <a:defRPr sz="1800" b="1">
+                <a:solidFill>
+                  <a:srgbClr val="B5E7ED"/>
+                </a:solidFill>
+                <a:latin typeface="DejaVu Sans"/>
+              </a:defRPr>
+            </a:pPr>
+            <a:r>
+              <a:t>A SU MEDIDA</a:t>
+            </a:r>
+          </a:p>
+        </p:txBody>
+      </p:sp>
+      <p:sp>
+        <p:nvSpPr>
+          <p:cNvPr id="13" name="TextBox 12"/>
+          <p:cNvSpPr txBox="1"/>
+          <p:nvPr/>
+        </p:nvSpPr>
+        <p:spPr>
+          <a:xfrm>
+            <a:off x="777240" y="4718304"/>
+            <a:ext cx="3035808" cy="640080"/>
+          </a:xfrm>
+          <a:prstGeom prst="rect">
+            <a:avLst/>
+          </a:prstGeom>
+          <a:noFill/>
+        </p:spPr>
+        <p:txBody>
+          <a:bodyPr wrap="square" lIns="0" rIns="0" tIns="0" bIns="0">
+            <a:spAutoFit/>
+          </a:bodyPr>
+          <a:lstStyle/>
+          <a:p>
+            <a:pPr>
+              <a:spcAft>
+                <a:spcPts val="700"/>
+              </a:spcAft>
+              <a:defRPr sz="1600" b="0">
                 <a:solidFill>
                   <a:srgbClr val="FFFFFF"/>
                 </a:solidFill>
@@ -4765,46 +4804,23 @@
               </a:defRPr>
             </a:pPr>
             <a:r>
-              <a:t>6 semanas</a:t>
-            </a:r>
-          </a:p>
-        </p:txBody>
-      </p:sp>
-      <p:sp>
-        <p:nvSpPr>
-          <p:cNvPr id="13" name="TextBox 12"/>
-          <p:cNvSpPr txBox="1"/>
-          <p:nvPr/>
-        </p:nvSpPr>
-        <p:spPr>
-          <a:xfrm>
-            <a:off x="777240" y="4882896"/>
-            <a:ext cx="3035808" cy="274320"/>
-          </a:xfrm>
-          <a:prstGeom prst="rect">
-            <a:avLst/>
-          </a:prstGeom>
-          <a:noFill/>
-        </p:spPr>
-        <p:txBody>
-          <a:bodyPr wrap="square" lIns="0" rIns="0" tIns="0" bIns="0">
-            <a:spAutoFit/>
-          </a:bodyPr>
-          <a:lstStyle/>
-          <a:p>
-            <a:pPr>
-              <a:spcAft>
-                <a:spcPts val="700"/>
-              </a:spcAft>
-              <a:defRPr sz="1300" b="0">
-                <a:solidFill>
-                  <a:srgbClr val="B5E7ED"/>
-                </a:solidFill>
-                <a:latin typeface="DejaVu Sans"/>
-              </a:defRPr>
-            </a:pPr>
-            <a:r>
-              <a:t>Plazo estimado</a:t>
+              <a:t>Procesos y permisos</a:t>
+            </a:r>
+          </a:p>
+          <a:p>
+            <a:pPr>
+              <a:spcAft>
+                <a:spcPts val="700"/>
+              </a:spcAft>
+              <a:defRPr sz="1600" b="0">
+                <a:solidFill>
+                  <a:srgbClr val="FFFFFF"/>
+                </a:solidFill>
+                <a:latin typeface="DejaVu Sans"/>
+              </a:defRPr>
+            </a:pPr>
+            <a:r>
+              <a:t>para su operación.</a:t>
             </a:r>
           </a:p>
         </p:txBody>
@@ -4849,24 +4865,63 @@
         <p:spPr>
           <a:xfrm>
             <a:off x="4471416" y="4114800"/>
-            <a:ext cx="3035808" cy="502920"/>
-          </a:xfrm>
-          <a:prstGeom prst="rect">
-            <a:avLst/>
-          </a:prstGeom>
-          <a:noFill/>
-        </p:spPr>
-        <p:txBody>
-          <a:bodyPr wrap="square" lIns="0" rIns="0" tIns="0" bIns="0">
-            <a:spAutoFit/>
-          </a:bodyPr>
-          <a:lstStyle/>
-          <a:p>
-            <a:pPr>
-              <a:spcAft>
-                <a:spcPts val="700"/>
-              </a:spcAft>
-              <a:defRPr sz="2700" b="1">
+            <a:ext cx="3035808" cy="411480"/>
+          </a:xfrm>
+          <a:prstGeom prst="rect">
+            <a:avLst/>
+          </a:prstGeom>
+          <a:noFill/>
+        </p:spPr>
+        <p:txBody>
+          <a:bodyPr wrap="square" lIns="0" rIns="0" tIns="0" bIns="0">
+            <a:spAutoFit/>
+          </a:bodyPr>
+          <a:lstStyle/>
+          <a:p>
+            <a:pPr>
+              <a:spcAft>
+                <a:spcPts val="700"/>
+              </a:spcAft>
+              <a:defRPr sz="1800" b="1">
+                <a:solidFill>
+                  <a:srgbClr val="B5E7ED"/>
+                </a:solidFill>
+                <a:latin typeface="DejaVu Sans"/>
+              </a:defRPr>
+            </a:pPr>
+            <a:r>
+              <a:t>TODO CONECTADO</a:t>
+            </a:r>
+          </a:p>
+        </p:txBody>
+      </p:sp>
+      <p:sp>
+        <p:nvSpPr>
+          <p:cNvPr id="16" name="TextBox 15"/>
+          <p:cNvSpPr txBox="1"/>
+          <p:nvPr/>
+        </p:nvSpPr>
+        <p:spPr>
+          <a:xfrm>
+            <a:off x="4471416" y="4718304"/>
+            <a:ext cx="3035808" cy="640080"/>
+          </a:xfrm>
+          <a:prstGeom prst="rect">
+            <a:avLst/>
+          </a:prstGeom>
+          <a:noFill/>
+        </p:spPr>
+        <p:txBody>
+          <a:bodyPr wrap="square" lIns="0" rIns="0" tIns="0" bIns="0">
+            <a:spAutoFit/>
+          </a:bodyPr>
+          <a:lstStyle/>
+          <a:p>
+            <a:pPr>
+              <a:spcAft>
+                <a:spcPts val="700"/>
+              </a:spcAft>
+              <a:defRPr sz="1600" b="0">
                 <a:solidFill>
                   <a:srgbClr val="FFFFFF"/>
                 </a:solidFill>
@@ -4874,46 +4929,23 @@
               </a:defRPr>
             </a:pPr>
             <a:r>
-              <a:t>S/ 3,500</a:t>
-            </a:r>
-          </a:p>
-        </p:txBody>
-      </p:sp>
-      <p:sp>
-        <p:nvSpPr>
-          <p:cNvPr id="16" name="TextBox 15"/>
-          <p:cNvSpPr txBox="1"/>
-          <p:nvPr/>
-        </p:nvSpPr>
-        <p:spPr>
-          <a:xfrm>
-            <a:off x="4471416" y="4882896"/>
-            <a:ext cx="3035808" cy="274320"/>
-          </a:xfrm>
-          <a:prstGeom prst="rect">
-            <a:avLst/>
-          </a:prstGeom>
-          <a:noFill/>
-        </p:spPr>
-        <p:txBody>
-          <a:bodyPr wrap="square" lIns="0" rIns="0" tIns="0" bIns="0">
-            <a:spAutoFit/>
-          </a:bodyPr>
-          <a:lstStyle/>
-          <a:p>
-            <a:pPr>
-              <a:spcAft>
-                <a:spcPts val="700"/>
-              </a:spcAft>
-              <a:defRPr sz="1300" b="0">
-                <a:solidFill>
-                  <a:srgbClr val="B5E7ED"/>
-                </a:solidFill>
-                <a:latin typeface="DejaVu Sans"/>
-              </a:defRPr>
-            </a:pPr>
-            <a:r>
-              <a:t>Inversión fija</a:t>
+              <a:t>Información para gestionar</a:t>
+            </a:r>
+          </a:p>
+          <a:p>
+            <a:pPr>
+              <a:spcAft>
+                <a:spcPts val="700"/>
+              </a:spcAft>
+              <a:defRPr sz="1600" b="0">
+                <a:solidFill>
+                  <a:srgbClr val="FFFFFF"/>
+                </a:solidFill>
+                <a:latin typeface="DejaVu Sans"/>
+              </a:defRPr>
+            </a:pPr>
+            <a:r>
+              <a:t>y tomar decisiones.</a:t>
             </a:r>
           </a:p>
         </p:txBody>
@@ -4958,24 +4990,63 @@
         <p:spPr>
           <a:xfrm>
             <a:off x="8165592" y="4114800"/>
-            <a:ext cx="3172968" cy="502920"/>
-          </a:xfrm>
-          <a:prstGeom prst="rect">
-            <a:avLst/>
-          </a:prstGeom>
-          <a:noFill/>
-        </p:spPr>
-        <p:txBody>
-          <a:bodyPr wrap="square" lIns="0" rIns="0" tIns="0" bIns="0">
-            <a:spAutoFit/>
-          </a:bodyPr>
-          <a:lstStyle/>
-          <a:p>
-            <a:pPr>
-              <a:spcAft>
-                <a:spcPts val="700"/>
-              </a:spcAft>
-              <a:defRPr sz="2700" b="1">
+            <a:ext cx="3172968" cy="411480"/>
+          </a:xfrm>
+          <a:prstGeom prst="rect">
+            <a:avLst/>
+          </a:prstGeom>
+          <a:noFill/>
+        </p:spPr>
+        <p:txBody>
+          <a:bodyPr wrap="square" lIns="0" rIns="0" tIns="0" bIns="0">
+            <a:spAutoFit/>
+          </a:bodyPr>
+          <a:lstStyle/>
+          <a:p>
+            <a:pPr>
+              <a:spcAft>
+                <a:spcPts val="700"/>
+              </a:spcAft>
+              <a:defRPr sz="1800" b="1">
+                <a:solidFill>
+                  <a:srgbClr val="B5E7ED"/>
+                </a:solidFill>
+                <a:latin typeface="DejaVu Sans"/>
+              </a:defRPr>
+            </a:pPr>
+            <a:r>
+              <a:t>SU EQUIPO</a:t>
+            </a:r>
+          </a:p>
+        </p:txBody>
+      </p:sp>
+      <p:sp>
+        <p:nvSpPr>
+          <p:cNvPr id="19" name="TextBox 18"/>
+          <p:cNvSpPr txBox="1"/>
+          <p:nvPr/>
+        </p:nvSpPr>
+        <p:spPr>
+          <a:xfrm>
+            <a:off x="8165592" y="4718304"/>
+            <a:ext cx="3172968" cy="640080"/>
+          </a:xfrm>
+          <a:prstGeom prst="rect">
+            <a:avLst/>
+          </a:prstGeom>
+          <a:noFill/>
+        </p:spPr>
+        <p:txBody>
+          <a:bodyPr wrap="square" lIns="0" rIns="0" tIns="0" bIns="0">
+            <a:spAutoFit/>
+          </a:bodyPr>
+          <a:lstStyle/>
+          <a:p>
+            <a:pPr>
+              <a:spcAft>
+                <a:spcPts val="700"/>
+              </a:spcAft>
+              <a:defRPr sz="1600" b="0">
                 <a:solidFill>
                   <a:srgbClr val="FFFFFF"/>
                 </a:solidFill>
@@ -4983,46 +5054,23 @@
               </a:defRPr>
             </a:pPr>
             <a:r>
-              <a:t>60 días</a:t>
-            </a:r>
-          </a:p>
-        </p:txBody>
-      </p:sp>
-      <p:sp>
-        <p:nvSpPr>
-          <p:cNvPr id="19" name="TextBox 18"/>
-          <p:cNvSpPr txBox="1"/>
-          <p:nvPr/>
-        </p:nvSpPr>
-        <p:spPr>
-          <a:xfrm>
-            <a:off x="8165592" y="4882896"/>
-            <a:ext cx="3172968" cy="274320"/>
-          </a:xfrm>
-          <a:prstGeom prst="rect">
-            <a:avLst/>
-          </a:prstGeom>
-          <a:noFill/>
-        </p:spPr>
-        <p:txBody>
-          <a:bodyPr wrap="square" lIns="0" rIns="0" tIns="0" bIns="0">
-            <a:spAutoFit/>
-          </a:bodyPr>
-          <a:lstStyle/>
-          <a:p>
-            <a:pPr>
-              <a:spcAft>
-                <a:spcPts val="700"/>
-              </a:spcAft>
-              <a:defRPr sz="1300" b="0">
-                <a:solidFill>
-                  <a:srgbClr val="B5E7ED"/>
-                </a:solidFill>
-                <a:latin typeface="DejaVu Sans"/>
-              </a:defRPr>
-            </a:pPr>
-            <a:r>
-              <a:t>Garantía posterior</a:t>
+              <a:t>Solicitudes, documentos</a:t>
+            </a:r>
+          </a:p>
+          <a:p>
+            <a:pPr>
+              <a:spcAft>
+                <a:spcPts val="700"/>
+              </a:spcAft>
+              <a:defRPr sz="1600" b="0">
+                <a:solidFill>
+                  <a:srgbClr val="FFFFFF"/>
+                </a:solidFill>
+                <a:latin typeface="DejaVu Sans"/>
+              </a:defRPr>
+            </a:pPr>
+            <a:r>
+              <a:t>y comunicación.</a:t>
             </a:r>
           </a:p>
         </p:txBody>
@@ -8011,7 +8059,7 @@
               </a:defRPr>
             </a:pPr>
             <a:r>
-              <a:t>EL OBJETIVO</a:t>
+              <a:t>EL PUNTO DE PARTIDA</a:t>
             </a:r>
           </a:p>
         </p:txBody>
@@ -8050,7 +8098,7 @@
               </a:defRPr>
             </a:pPr>
             <a:r>
-              <a:t>Una gestión de personal centralizada.</a:t>
+              <a:t>La experiencia de MARKINT con Buk.</a:t>
             </a:r>
           </a:p>
         </p:txBody>
@@ -8089,7 +8137,7 @@
               </a:defRPr>
             </a:pPr>
             <a:r>
-              <a:t>Información disponible para cada usuario según su responsabilidad.</a:t>
+              <a:t>Una propuesta de plataforma propia, definida desde sus procesos y prioridades.</a:t>
             </a:r>
           </a:p>
         </p:txBody>
@@ -8266,7 +8314,7 @@
               </a:defRPr>
             </a:pPr>
             <a:r>
-              <a:t>ORGANIZAR</a:t>
+              <a:t>SU OPERACIÓN</a:t>
             </a:r>
           </a:p>
         </p:txBody>
@@ -8305,7 +8353,7 @@
               </a:defRPr>
             </a:pPr>
             <a:r>
-              <a:t>Expedientes, contratos, documentos e historial del personal.</a:t>
+              <a:t>Partir de los procesos que el equipo ya conoce y utiliza.</a:t>
             </a:r>
           </a:p>
         </p:txBody>
@@ -8375,7 +8423,7 @@
               </a:defRPr>
             </a:pPr>
             <a:r>
-              <a:t>AGILIZAR</a:t>
+              <a:t>SUS PRIORIDADES</a:t>
             </a:r>
           </a:p>
         </p:txBody>
@@ -8414,7 +8462,7 @@
               </a:defRPr>
             </a:pPr>
             <a:r>
-              <a:t>Horarios, asistencia, solicitudes y validaciones administrativas.</a:t>
+              <a:t>Definir flujos, responsabilidades e información para MARKINT.</a:t>
             </a:r>
           </a:p>
         </p:txBody>
@@ -8484,7 +8532,7 @@
               </a:defRPr>
             </a:pPr>
             <a:r>
-              <a:t>CONECTAR</a:t>
+              <a:t>SU PLATAFORMA</a:t>
             </a:r>
           </a:p>
         </p:txBody>
@@ -8523,7 +8571,7 @@
               </a:defRPr>
             </a:pPr>
             <a:r>
-              <a:t>Planilla, boletas, encuestas y comunicación interna.</a:t>
+              <a:t>Diseñar una experiencia web para colaboradores, jefaturas y RRHH.</a:t>
             </a:r>
           </a:p>
         </p:txBody>

</xml_diff>